<commit_message>
docs: record native vector clipboard acceptance in Word and PowerPoint
</commit_message>
<xml_diff>
--- a/examples/vector/Word to PowerPoint.pptx
+++ b/examples/vector/Word to PowerPoint.pptx
@@ -3305,69 +3305,69 @@
 </file>
 
 <file path=ppt/slides/slide1.xml><?xml version="1.0" encoding="utf-8"?>
-<p:sld xmlns:a="http://schemas.openxmlformats.org/drawingml/2006/main" xmlns:r="http://schemas.openxmlformats.org/officeDocument/2006/relationships" xmlns:p="http://schemas.openxmlformats.org/presentationml/2006/main">
-  <p:cSld>
-    <p:spTree>
-      <p:nvGrpSpPr>
-        <p:cNvPr id="1" name=""/>
-        <p:cNvGrpSpPr/>
-        <p:nvPr/>
-      </p:nvGrpSpPr>
-      <p:grpSpPr>
-        <a:xfrm>
-          <a:off x="0" y="0"/>
-          <a:ext cx="0" cy="0"/>
-          <a:chOff x="0" y="0"/>
-          <a:chExt cx="0" cy="0"/>
-        </a:xfrm>
-      </p:grpSpPr>
-      <p:pic>
-        <p:nvPicPr>
-          <p:cNvPr id="3" name="ChemOffice Drawing:aae3e69b-342c-4047-9592-2510a337a9c6">
-            <a:extLst>
-              <a:ext uri="{FF2B5EF4-FFF2-40B4-BE49-F238E27FC236}">
-                <a16:creationId xmlns:a16="http://schemas.microsoft.com/office/drawing/2014/main" id="{1EED8361-16B5-453B-BBC0-BE24EF6B7285}"/>
-              </a:ext>
-            </a:extLst>
-          </p:cNvPr>
-          <p:cNvPicPr>
-            <a:picLocks/>
-          </p:cNvPicPr>
-          <p:nvPr/>
-        </p:nvPicPr>
-        <p:blipFill>
-          <a:blip>
-            <a:extLst>
-              <a:ext uri="{96DAC541-7B7A-43D3-8B79-37D633B846F1}">
-                <asvg:svgBlip xmlns:asvg="http://schemas.microsoft.com/office/drawing/2016/SVG/main" r:embed="rId2"/>
-              </a:ext>
-            </a:extLst>
-          </a:blip>
-          <a:stretch>
-            <a:fillRect/>
-          </a:stretch>
-        </p:blipFill>
-        <p:spPr>
-          <a:xfrm>
-            <a:off x="1524000" y="1524000"/>
-            <a:ext cx="5080000" cy="5080000"/>
-          </a:xfrm>
-          <a:prstGeom prst="rect">
-            <a:avLst/>
-          </a:prstGeom>
-        </p:spPr>
-      </p:pic>
-    </p:spTree>
-    <p:extLst>
-      <p:ext uri="{BB962C8B-B14F-4D97-AF65-F5344CB8AC3E}">
-        <p14:creationId xmlns:p14="http://schemas.microsoft.com/office/powerpoint/2010/main" val="1916069495"/>
-      </p:ext>
-    </p:extLst>
-  </p:cSld>
-  <p:clrMapOvr>
-    <a:masterClrMapping/>
-  </p:clrMapOvr>
-</p:sld>
+<ns0:sld xmlns:ns0="http://schemas.openxmlformats.org/presentationml/2006/main" xmlns:ns1="http://schemas.openxmlformats.org/drawingml/2006/main" xmlns:ns2="http://schemas.microsoft.com/office/drawing/2014/main" xmlns:ns3="http://schemas.microsoft.com/office/drawing/2016/SVG/main" xmlns:ns4="http://schemas.openxmlformats.org/officeDocument/2006/relationships" xmlns:ns5="http://schemas.microsoft.com/office/powerpoint/2010/main">
+  <ns0:cSld>
+    <ns0:spTree>
+      <ns0:nvGrpSpPr>
+        <ns0:cNvPr id="1" name=""/>
+        <ns0:cNvGrpSpPr/>
+        <ns0:nvPr/>
+      </ns0:nvGrpSpPr>
+      <ns0:grpSpPr>
+        <ns1:xfrm>
+          <ns1:off x="0" y="0"/>
+          <ns1:ext cx="0" cy="0"/>
+          <ns1:chOff x="0" y="0"/>
+          <ns1:chExt cx="0" cy="0"/>
+        </ns1:xfrm>
+      </ns0:grpSpPr>
+      <ns0:pic>
+        <ns0:nvPicPr>
+          <ns0:cNvPr id="3" name="ChemOffice Drawing:aae3e69b-342c-4047-9592-2510a337a9c6">
+            <ns1:extLst>
+              <ns1:ext uri="{FF2B5EF4-FFF2-40B4-BE49-F238E27FC236}">
+                <ns2:creationId id="{1EED8361-16B5-453B-BBC0-BE24EF6B7285}"/>
+              </ns1:ext>
+            </ns1:extLst>
+          </ns0:cNvPr>
+          <ns0:cNvPicPr>
+            <ns1:picLocks/>
+          </ns0:cNvPicPr>
+          <ns0:nvPr/>
+        </ns0:nvPicPr>
+        <ns0:blipFill>
+          <ns1:blip>
+            <ns1:extLst>
+              <ns1:ext uri="{96DAC541-7B7A-43D3-8B79-37D633B846F1}">
+                <ns3:svgBlip ns4:embed="rId2"/>
+              </ns1:ext>
+            </ns1:extLst>
+          </ns1:blip>
+          <ns1:stretch>
+            <ns1:fillRect/>
+          </ns1:stretch>
+        </ns0:blipFill>
+        <ns0:spPr>
+          <ns1:xfrm>
+            <ns1:off x="1524000" y="1524000"/>
+            <ns1:ext cx="5080000" cy="2382345"/>
+          </ns1:xfrm>
+          <ns1:prstGeom prst="rect">
+            <ns1:avLst/>
+          </ns1:prstGeom>
+        </ns0:spPr>
+      </ns0:pic>
+    </ns0:spTree>
+    <ns0:extLst>
+      <ns0:ext uri="{BB962C8B-B14F-4D97-AF65-F5344CB8AC3E}">
+        <ns5:creationId val="1916069495"/>
+      </ns0:ext>
+    </ns0:extLst>
+  </ns0:cSld>
+  <ns0:clrMapOvr>
+    <ns1:masterClrMapping/>
+  </ns0:clrMapOvr>
+</ns0:sld>
 </file>
 
 <file path=ppt/theme/theme1.xml><?xml version="1.0" encoding="utf-8"?>

</xml_diff>